<commit_message>
fix: Remove sample slides from templates and fix template auto-loading
- create_templates.py: Delete all slides after styling (keep layout defs only)
  Removes OPC part rels + sldIdLst refs to avoid duplicate ZIP entry warnings
- create_slides.py: Add _resolve_template() to auto-resolve metadata.template
  ("tech"/"casual"/"formal") to built-in template PPTX paths
- SKILL.md: Recommend file-based input over echo pipe to avoid 32KB limit

🤖 Generated with Claude Code

Co-Authored-By: Claude <noreply@anthropic.com>
</commit_message>
<xml_diff>
--- a/.claude/skills/daida-ai/assets/templates/casual.pptx
+++ b/.claude/skills/daida-ai/assets/templates/casual.pptx
@@ -4,14 +4,7 @@
   <p:sldMasterIdLst>
     <p:sldMasterId id="2147483648" r:id="rId1"/>
   </p:sldMasterIdLst>
-  <p:sldIdLst>
-    <p:sldId id="256" r:id="rId7"/>
-    <p:sldId id="257" r:id="rId8"/>
-    <p:sldId id="258" r:id="rId9"/>
-    <p:sldId id="259" r:id="rId10"/>
-    <p:sldId id="260" r:id="rId11"/>
-    <p:sldId id="261" r:id="rId12"/>
-  </p:sldIdLst>
+  <p:sldIdLst/>
   <p:sldSz cx="12191695" cy="6858000" type="screen4x3"/>
   <p:notesSz cx="6858000" cy="9144000"/>
   <p:defaultTextStyle>
@@ -3081,503 +3074,6 @@
     </p:otherStyle>
   </p:txStyles>
 </p:sldMaster>
-</file>
-
-<file path=ppt/slides/slide1.xml><?xml version="1.0" encoding="utf-8"?>
-<p:sld xmlns:a="http://schemas.openxmlformats.org/drawingml/2006/main" xmlns:p="http://schemas.openxmlformats.org/presentationml/2006/main" xmlns:r="http://schemas.openxmlformats.org/officeDocument/2006/relationships">
-  <p:cSld>
-    <p:bg>
-      <p:bgPr>
-        <a:solidFill>
-          <a:srgbClr val="FFFFFF"/>
-        </a:solidFill>
-        <a:effectLst/>
-      </p:bgPr>
-    </p:bg>
-    <p:spTree>
-      <p:nvGrpSpPr>
-        <p:cNvPr id="1" name=""/>
-        <p:cNvGrpSpPr/>
-        <p:nvPr/>
-      </p:nvGrpSpPr>
-      <p:grpSpPr/>
-      <p:sp>
-        <p:nvSpPr>
-          <p:cNvPr id="2" name="Title 1"/>
-          <p:cNvSpPr>
-            <a:spLocks noGrp="1"/>
-          </p:cNvSpPr>
-          <p:nvPr>
-            <p:ph type="ctrTitle"/>
-          </p:nvPr>
-        </p:nvSpPr>
-        <p:spPr/>
-        <p:txBody>
-          <a:bodyPr/>
-          <a:lstStyle/>
-          <a:p>
-            <a:pPr algn="ctr">
-              <a:defRPr sz="4400" b="1">
-                <a:solidFill>
-                  <a:srgbClr val="2D3A8C"/>
-                </a:solidFill>
-              </a:defRPr>
-            </a:pPr>
-            <a:r>
-              <a:t>プレゼンテーションタイトル</a:t>
-            </a:r>
-          </a:p>
-        </p:txBody>
-      </p:sp>
-      <p:sp>
-        <p:nvSpPr>
-          <p:cNvPr id="3" name="Subtitle 2"/>
-          <p:cNvSpPr>
-            <a:spLocks noGrp="1"/>
-          </p:cNvSpPr>
-          <p:nvPr>
-            <p:ph type="subTitle" idx="1"/>
-          </p:nvPr>
-        </p:nvSpPr>
-        <p:spPr/>
-        <p:txBody>
-          <a:bodyPr/>
-          <a:lstStyle/>
-          <a:p>
-            <a:pPr algn="ctr">
-              <a:defRPr sz="2400" b="0">
-                <a:solidFill>
-                  <a:srgbClr val="666666"/>
-                </a:solidFill>
-              </a:defRPr>
-            </a:pPr>
-            <a:r>
-              <a:t>サブタイトル / 登壇者名</a:t>
-            </a:r>
-          </a:p>
-        </p:txBody>
-      </p:sp>
-    </p:spTree>
-  </p:cSld>
-  <p:clrMapOvr>
-    <a:masterClrMapping/>
-  </p:clrMapOvr>
-</p:sld>
-</file>
-
-<file path=ppt/slides/slide2.xml><?xml version="1.0" encoding="utf-8"?>
-<p:sld xmlns:a="http://schemas.openxmlformats.org/drawingml/2006/main" xmlns:p="http://schemas.openxmlformats.org/presentationml/2006/main" xmlns:r="http://schemas.openxmlformats.org/officeDocument/2006/relationships">
-  <p:cSld>
-    <p:bg>
-      <p:bgPr>
-        <a:solidFill>
-          <a:srgbClr val="FFFFFF"/>
-        </a:solidFill>
-        <a:effectLst/>
-      </p:bgPr>
-    </p:bg>
-    <p:spTree>
-      <p:nvGrpSpPr>
-        <p:cNvPr id="1" name=""/>
-        <p:cNvGrpSpPr/>
-        <p:nvPr/>
-      </p:nvGrpSpPr>
-      <p:grpSpPr/>
-      <p:sp>
-        <p:nvSpPr>
-          <p:cNvPr id="2" name="Title 1"/>
-          <p:cNvSpPr>
-            <a:spLocks noGrp="1"/>
-          </p:cNvSpPr>
-          <p:nvPr>
-            <p:ph type="title"/>
-          </p:nvPr>
-        </p:nvSpPr>
-        <p:spPr/>
-        <p:txBody>
-          <a:bodyPr/>
-          <a:lstStyle/>
-          <a:p>
-            <a:pPr>
-              <a:defRPr sz="3600" b="1">
-                <a:solidFill>
-                  <a:srgbClr val="2D3A8C"/>
-                </a:solidFill>
-              </a:defRPr>
-            </a:pPr>
-            <a:r>
-              <a:t>スライドタイトル</a:t>
-            </a:r>
-          </a:p>
-        </p:txBody>
-      </p:sp>
-      <p:sp>
-        <p:nvSpPr>
-          <p:cNvPr id="3" name="Content Placeholder 2"/>
-          <p:cNvSpPr>
-            <a:spLocks noGrp="1"/>
-          </p:cNvSpPr>
-          <p:nvPr>
-            <p:ph idx="1"/>
-          </p:nvPr>
-        </p:nvSpPr>
-        <p:spPr/>
-        <p:txBody>
-          <a:bodyPr/>
-          <a:lstStyle/>
-          <a:p>
-            <a:pPr>
-              <a:defRPr sz="2400">
-                <a:solidFill>
-                  <a:srgbClr val="333333"/>
-                </a:solidFill>
-              </a:defRPr>
-            </a:pPr>
-            <a:r>
-              <a:t>ポイント1: 具体的な内容</a:t>
-            </a:r>
-          </a:p>
-          <a:p>
-            <a:pPr>
-              <a:defRPr sz="2400">
-                <a:solidFill>
-                  <a:srgbClr val="333333"/>
-                </a:solidFill>
-              </a:defRPr>
-            </a:pPr>
-            <a:r>
-              <a:t>ポイント2: データや数値</a:t>
-            </a:r>
-          </a:p>
-          <a:p>
-            <a:pPr>
-              <a:defRPr sz="2400">
-                <a:solidFill>
-                  <a:srgbClr val="333333"/>
-                </a:solidFill>
-              </a:defRPr>
-            </a:pPr>
-            <a:r>
-              <a:t>ポイント3: まとめ</a:t>
-            </a:r>
-          </a:p>
-        </p:txBody>
-      </p:sp>
-    </p:spTree>
-  </p:cSld>
-  <p:clrMapOvr>
-    <a:masterClrMapping/>
-  </p:clrMapOvr>
-</p:sld>
-</file>
-
-<file path=ppt/slides/slide3.xml><?xml version="1.0" encoding="utf-8"?>
-<p:sld xmlns:a="http://schemas.openxmlformats.org/drawingml/2006/main" xmlns:p="http://schemas.openxmlformats.org/presentationml/2006/main" xmlns:r="http://schemas.openxmlformats.org/officeDocument/2006/relationships">
-  <p:cSld>
-    <p:bg>
-      <p:bgPr>
-        <a:solidFill>
-          <a:srgbClr val="F0F4FF"/>
-        </a:solidFill>
-        <a:effectLst/>
-      </p:bgPr>
-    </p:bg>
-    <p:spTree>
-      <p:nvGrpSpPr>
-        <p:cNvPr id="1" name=""/>
-        <p:cNvGrpSpPr/>
-        <p:nvPr/>
-      </p:nvGrpSpPr>
-      <p:grpSpPr/>
-      <p:sp>
-        <p:nvSpPr>
-          <p:cNvPr id="2" name="Title 1"/>
-          <p:cNvSpPr>
-            <a:spLocks noGrp="1"/>
-          </p:cNvSpPr>
-          <p:nvPr>
-            <p:ph type="title"/>
-          </p:nvPr>
-        </p:nvSpPr>
-        <p:spPr/>
-        <p:txBody>
-          <a:bodyPr/>
-          <a:lstStyle/>
-          <a:p>
-            <a:pPr algn="ctr">
-              <a:defRPr sz="4000" b="1">
-                <a:solidFill>
-                  <a:srgbClr val="2D3A8C"/>
-                </a:solidFill>
-              </a:defRPr>
-            </a:pPr>
-            <a:r>
-              <a:t>セクションタイトル</a:t>
-            </a:r>
-          </a:p>
-        </p:txBody>
-      </p:sp>
-      <p:sp>
-        <p:nvSpPr>
-          <p:cNvPr id="3" name="Text Placeholder 2"/>
-          <p:cNvSpPr>
-            <a:spLocks noGrp="1"/>
-          </p:cNvSpPr>
-          <p:nvPr>
-            <p:ph type="body" idx="1"/>
-          </p:nvPr>
-        </p:nvSpPr>
-        <p:spPr/>
-        <p:txBody>
-          <a:bodyPr/>
-          <a:lstStyle/>
-          <a:p/>
-        </p:txBody>
-      </p:sp>
-    </p:spTree>
-  </p:cSld>
-  <p:clrMapOvr>
-    <a:masterClrMapping/>
-  </p:clrMapOvr>
-</p:sld>
-</file>
-
-<file path=ppt/slides/slide4.xml><?xml version="1.0" encoding="utf-8"?>
-<p:sld xmlns:a="http://schemas.openxmlformats.org/drawingml/2006/main" xmlns:p="http://schemas.openxmlformats.org/presentationml/2006/main" xmlns:r="http://schemas.openxmlformats.org/officeDocument/2006/relationships">
-  <p:cSld>
-    <p:bg>
-      <p:bgPr>
-        <a:solidFill>
-          <a:srgbClr val="FFFFFF"/>
-        </a:solidFill>
-        <a:effectLst/>
-      </p:bgPr>
-    </p:bg>
-    <p:spTree>
-      <p:nvGrpSpPr>
-        <p:cNvPr id="1" name=""/>
-        <p:cNvGrpSpPr/>
-        <p:nvPr/>
-      </p:nvGrpSpPr>
-      <p:grpSpPr/>
-      <p:sp>
-        <p:nvSpPr>
-          <p:cNvPr id="2" name="Title 1"/>
-          <p:cNvSpPr>
-            <a:spLocks noGrp="1"/>
-          </p:cNvSpPr>
-          <p:nvPr>
-            <p:ph type="title"/>
-          </p:nvPr>
-        </p:nvSpPr>
-        <p:spPr/>
-        <p:txBody>
-          <a:bodyPr/>
-          <a:lstStyle/>
-          <a:p>
-            <a:pPr>
-              <a:defRPr sz="3600" b="1">
-                <a:solidFill>
-                  <a:srgbClr val="2D3A8C"/>
-                </a:solidFill>
-              </a:defRPr>
-            </a:pPr>
-            <a:r>
-              <a:t>比較タイトル</a:t>
-            </a:r>
-          </a:p>
-        </p:txBody>
-      </p:sp>
-      <p:sp>
-        <p:nvSpPr>
-          <p:cNvPr id="3" name="Content Placeholder 2"/>
-          <p:cNvSpPr>
-            <a:spLocks noGrp="1"/>
-          </p:cNvSpPr>
-          <p:nvPr>
-            <p:ph idx="1" sz="half"/>
-          </p:nvPr>
-        </p:nvSpPr>
-        <p:spPr/>
-        <p:txBody>
-          <a:bodyPr/>
-          <a:lstStyle/>
-          <a:p>
-            <a:pPr>
-              <a:defRPr sz="2200" b="1">
-                <a:solidFill>
-                  <a:srgbClr val="FF6B35"/>
-                </a:solidFill>
-              </a:defRPr>
-            </a:pPr>
-            <a:r>
-              <a:t>左カラム見出し</a:t>
-            </a:r>
-          </a:p>
-          <a:p>
-            <a:pPr>
-              <a:defRPr sz="2000">
-                <a:solidFill>
-                  <a:srgbClr val="333333"/>
-                </a:solidFill>
-              </a:defRPr>
-            </a:pPr>
-            <a:r>
-              <a:t>項目A</a:t>
-            </a:r>
-          </a:p>
-          <a:p>
-            <a:pPr>
-              <a:defRPr sz="2000">
-                <a:solidFill>
-                  <a:srgbClr val="333333"/>
-                </a:solidFill>
-              </a:defRPr>
-            </a:pPr>
-            <a:r>
-              <a:t>項目B</a:t>
-            </a:r>
-          </a:p>
-        </p:txBody>
-      </p:sp>
-      <p:sp>
-        <p:nvSpPr>
-          <p:cNvPr id="4" name="Content Placeholder 3"/>
-          <p:cNvSpPr>
-            <a:spLocks noGrp="1"/>
-          </p:cNvSpPr>
-          <p:nvPr>
-            <p:ph idx="2" sz="half"/>
-          </p:nvPr>
-        </p:nvSpPr>
-        <p:spPr/>
-        <p:txBody>
-          <a:bodyPr/>
-          <a:lstStyle/>
-          <a:p>
-            <a:pPr>
-              <a:defRPr sz="2200" b="1">
-                <a:solidFill>
-                  <a:srgbClr val="FF6B35"/>
-                </a:solidFill>
-              </a:defRPr>
-            </a:pPr>
-            <a:r>
-              <a:t>右カラム見出し</a:t>
-            </a:r>
-          </a:p>
-          <a:p>
-            <a:pPr>
-              <a:defRPr sz="2000">
-                <a:solidFill>
-                  <a:srgbClr val="333333"/>
-                </a:solidFill>
-              </a:defRPr>
-            </a:pPr>
-            <a:r>
-              <a:t>項目A</a:t>
-            </a:r>
-          </a:p>
-          <a:p>
-            <a:pPr>
-              <a:defRPr sz="2000">
-                <a:solidFill>
-                  <a:srgbClr val="333333"/>
-                </a:solidFill>
-              </a:defRPr>
-            </a:pPr>
-            <a:r>
-              <a:t>項目B</a:t>
-            </a:r>
-          </a:p>
-        </p:txBody>
-      </p:sp>
-    </p:spTree>
-  </p:cSld>
-  <p:clrMapOvr>
-    <a:masterClrMapping/>
-  </p:clrMapOvr>
-</p:sld>
-</file>
-
-<file path=ppt/slides/slide5.xml><?xml version="1.0" encoding="utf-8"?>
-<p:sld xmlns:a="http://schemas.openxmlformats.org/drawingml/2006/main" xmlns:p="http://schemas.openxmlformats.org/presentationml/2006/main" xmlns:r="http://schemas.openxmlformats.org/officeDocument/2006/relationships">
-  <p:cSld>
-    <p:bg>
-      <p:bgPr>
-        <a:solidFill>
-          <a:srgbClr val="FFFFFF"/>
-        </a:solidFill>
-        <a:effectLst/>
-      </p:bgPr>
-    </p:bg>
-    <p:spTree>
-      <p:nvGrpSpPr>
-        <p:cNvPr id="1" name=""/>
-        <p:cNvGrpSpPr/>
-        <p:nvPr/>
-      </p:nvGrpSpPr>
-      <p:grpSpPr/>
-      <p:sp>
-        <p:nvSpPr>
-          <p:cNvPr id="2" name="Title 1"/>
-          <p:cNvSpPr>
-            <a:spLocks noGrp="1"/>
-          </p:cNvSpPr>
-          <p:nvPr>
-            <p:ph type="title"/>
-          </p:nvPr>
-        </p:nvSpPr>
-        <p:spPr/>
-        <p:txBody>
-          <a:bodyPr/>
-          <a:lstStyle/>
-          <a:p>
-            <a:pPr>
-              <a:defRPr sz="3600" b="1">
-                <a:solidFill>
-                  <a:srgbClr val="2D3A8C"/>
-                </a:solidFill>
-              </a:defRPr>
-            </a:pPr>
-            <a:r>
-              <a:t>図・画像用スライド</a:t>
-            </a:r>
-          </a:p>
-        </p:txBody>
-      </p:sp>
-    </p:spTree>
-  </p:cSld>
-  <p:clrMapOvr>
-    <a:masterClrMapping/>
-  </p:clrMapOvr>
-</p:sld>
-</file>
-
-<file path=ppt/slides/slide6.xml><?xml version="1.0" encoding="utf-8"?>
-<p:sld xmlns:a="http://schemas.openxmlformats.org/drawingml/2006/main" xmlns:p="http://schemas.openxmlformats.org/presentationml/2006/main" xmlns:r="http://schemas.openxmlformats.org/officeDocument/2006/relationships">
-  <p:cSld>
-    <p:bg>
-      <p:bgPr>
-        <a:solidFill>
-          <a:srgbClr val="FFFFFF"/>
-        </a:solidFill>
-        <a:effectLst/>
-      </p:bgPr>
-    </p:bg>
-    <p:spTree>
-      <p:nvGrpSpPr>
-        <p:cNvPr id="1" name=""/>
-        <p:cNvGrpSpPr/>
-        <p:nvPr/>
-      </p:nvGrpSpPr>
-      <p:grpSpPr/>
-    </p:spTree>
-  </p:cSld>
-  <p:clrMapOvr>
-    <a:masterClrMapping/>
-  </p:clrMapOvr>
-</p:sld>
 </file>
 
 <file path=ppt/theme/theme1.xml><?xml version="1.0" encoding="utf-8"?>

</xml_diff>